<commit_message>
Add reusable chart functions and profit-impact findings; update README
</commit_message>
<xml_diff>
--- a/data/anomaly_detection_summary.pptx
+++ b/data/anomaly_detection_summary.pptx
@@ -117,26 +117,26 @@
   <pc:docChgLst>
     <pc:chgData name="Thomas Hoe" userId="5ab09498c29fe2eb" providerId="LiveId" clId="{C9C82A5D-B877-4EFD-9497-F73431ACD859}"/>
     <pc:docChg chg="custSel modSld">
-      <pc:chgData name="Thomas Hoe" userId="5ab09498c29fe2eb" providerId="LiveId" clId="{C9C82A5D-B877-4EFD-9497-F73431ACD859}" dt="2026-09-30T06:27:36.630" v="1" actId="478"/>
+      <pc:chgData name="Thomas Hoe" userId="5ab09498c29fe2eb" providerId="LiveId" clId="{C9C82A5D-B877-4EFD-9497-F73431ACD859}" dt="2026-09-30T06:27:19.264" v="0" actId="478"/>
       <pc:docMkLst>
         <pc:docMk/>
       </pc:docMkLst>
       <pc:sldChg chg="addSp delSp modSp mod">
-        <pc:chgData name="Thomas Hoe" userId="5ab09498c29fe2eb" providerId="LiveId" clId="{C9C82A5D-B877-4EFD-9497-F73431ACD859}" dt="2026-09-30T06:27:36.630" v="1" actId="478"/>
+        <pc:chgData name="Thomas Hoe" userId="5ab09498c29fe2eb" providerId="LiveId" clId="{C9C82A5D-B877-4EFD-9497-F73431ACD859}" dt="2026-09-30T06:27:19.264" v="0" actId="478"/>
         <pc:sldMkLst>
           <pc:docMk/>
           <pc:sldMk cId="4052130581" sldId="256"/>
         </pc:sldMkLst>
-        <pc:spChg chg="add del mod">
-          <ac:chgData name="Thomas Hoe" userId="5ab09498c29fe2eb" providerId="LiveId" clId="{C9C82A5D-B877-4EFD-9497-F73431ACD859}" dt="2026-09-30T06:27:36.630" v="1" actId="478"/>
+        <pc:spChg chg="add mod">
+          <ac:chgData name="Thomas Hoe" userId="5ab09498c29fe2eb" providerId="LiveId" clId="{C9C82A5D-B877-4EFD-9497-F73431ACD859}" dt="2026-09-30T06:27:19.264" v="0" actId="478"/>
           <ac:spMkLst>
             <pc:docMk/>
             <pc:sldMk cId="4052130581" sldId="256"/>
-            <ac:spMk id="3" creationId="{76B6CAFB-EA41-27CC-4F32-7209934CF2EE}"/>
+            <ac:spMk id="3" creationId="{FBE32540-F9D7-BF54-E16F-343300C18343}"/>
           </ac:spMkLst>
         </pc:spChg>
         <pc:spChg chg="del">
-          <ac:chgData name="Thomas Hoe" userId="5ab09498c29fe2eb" providerId="LiveId" clId="{C9C82A5D-B877-4EFD-9497-F73431ACD859}" dt="2026-09-30T06:27:31.883" v="0" actId="478"/>
+          <ac:chgData name="Thomas Hoe" userId="5ab09498c29fe2eb" providerId="LiveId" clId="{C9C82A5D-B877-4EFD-9497-F73431ACD859}" dt="2026-09-30T06:27:19.264" v="0" actId="478"/>
           <ac:spMkLst>
             <pc:docMk/>
             <pc:sldMk cId="4052130581" sldId="256"/>
@@ -3386,7 +3386,32 @@
       </p:grpSpPr>
       <p:sp>
         <p:nvSpPr>
-          <p:cNvPr id="5" name="TextBox 4"/>
+          <p:cNvPr id="3" name="Title 2">
+            <a:extLst>
+              <a:ext uri="{FF2B5EF4-FFF2-40B4-BE49-F238E27FC236}">
+                <a16:creationId xmlns:a16="http://schemas.microsoft.com/office/drawing/2014/main" id="{FBE32540-F9D7-BF54-E16F-343300C18343}"/>
+              </a:ext>
+            </a:extLst>
+          </p:cNvPr>
+          <p:cNvSpPr>
+            <a:spLocks noGrp="1"/>
+          </p:cNvSpPr>
+          <p:nvPr>
+            <p:ph type="title"/>
+          </p:nvPr>
+        </p:nvSpPr>
+        <p:spPr/>
+        <p:txBody>
+          <a:bodyPr/>
+          <a:lstStyle/>
+          <a:p>
+            <a:endParaRPr lang="en-SG"/>
+          </a:p>
+        </p:txBody>
+      </p:sp>
+      <p:sp>
+        <p:nvSpPr>
+          <p:cNvPr id="4" name="TextBox 3"/>
           <p:cNvSpPr txBox="1"/>
           <p:nvPr/>
         </p:nvSpPr>
@@ -3415,7 +3440,7 @@
       </p:sp>
       <p:pic>
         <p:nvPicPr>
-          <p:cNvPr id="6" name="Picture 5" descr="discount_boxplot.png"/>
+          <p:cNvPr id="5" name="Picture 4" descr="discount_boxplot.png"/>
           <p:cNvPicPr>
             <a:picLocks noChangeAspect="1"/>
           </p:cNvPicPr>
@@ -3439,7 +3464,7 @@
       </p:pic>
       <p:sp>
         <p:nvSpPr>
-          <p:cNvPr id="7" name="TextBox 6"/>
+          <p:cNvPr id="6" name="TextBox 5"/>
           <p:cNvSpPr txBox="1"/>
           <p:nvPr/>
         </p:nvSpPr>
@@ -3474,7 +3499,7 @@
       </p:sp>
       <p:sp>
         <p:nvSpPr>
-          <p:cNvPr id="8" name="TextBox 7"/>
+          <p:cNvPr id="7" name="TextBox 6"/>
           <p:cNvSpPr txBox="1"/>
           <p:nvPr/>
         </p:nvSpPr>

</xml_diff>

<commit_message>
Add slide 2 (profit by Region x Category); fix slide text and placeholders
</commit_message>
<xml_diff>
--- a/data/anomaly_detection_summary.pptx
+++ b/data/anomaly_detection_summary.pptx
@@ -6,6 +6,7 @@
   </p:sldMasterIdLst>
   <p:sldIdLst>
     <p:sldId id="256" r:id="rId2"/>
+    <p:sldId id="257" r:id="rId8"/>
   </p:sldIdLst>
   <p:sldSz cx="12192000" cy="6858000"/>
   <p:notesSz cx="6858000" cy="9144000"/>
@@ -3386,31 +3387,6 @@
       </p:grpSpPr>
       <p:sp>
         <p:nvSpPr>
-          <p:cNvPr id="3" name="Title 2">
-            <a:extLst>
-              <a:ext uri="{FF2B5EF4-FFF2-40B4-BE49-F238E27FC236}">
-                <a16:creationId xmlns:a16="http://schemas.microsoft.com/office/drawing/2014/main" id="{FBE32540-F9D7-BF54-E16F-343300C18343}"/>
-              </a:ext>
-            </a:extLst>
-          </p:cNvPr>
-          <p:cNvSpPr>
-            <a:spLocks noGrp="1"/>
-          </p:cNvSpPr>
-          <p:nvPr>
-            <p:ph type="title"/>
-          </p:nvPr>
-        </p:nvSpPr>
-        <p:spPr/>
-        <p:txBody>
-          <a:bodyPr/>
-          <a:lstStyle/>
-          <a:p>
-            <a:endParaRPr lang="en-SG"/>
-          </a:p>
-        </p:txBody>
-      </p:sp>
-      <p:sp>
-        <p:nvSpPr>
           <p:cNvPr id="4" name="TextBox 3"/>
           <p:cNvSpPr txBox="1"/>
           <p:nvPr/>
@@ -3440,7 +3416,7 @@
       </p:sp>
       <p:pic>
         <p:nvPicPr>
-          <p:cNvPr id="5" name="Picture 4" descr="discount_boxplot.png"/>
+          <p:cNvPr id="5" name="Picture 4" descr="discount_by_category.png"/>
           <p:cNvPicPr>
             <a:picLocks noChangeAspect="1"/>
           </p:cNvPicPr>
@@ -3492,7 +3468,7 @@
           <a:p>
             <a:r>
               <a:rPr sz="1200"/>
-              <a:t>Q2 (order-level discount): 703 of 9,994 orders (~7%) flagged as unusually high discount vs. their Category norm — concentrated in Office Supplies at 70–80% discount.</a:t>
+              <a:t>Q2 (order-level discount): 703 of 9,994 orders (~7%) flagged as unusually high discount vs. their Category norm — in Office Supplies (70–80%) and Technology (70%).</a:t>
             </a:r>
           </a:p>
         </p:txBody>
@@ -3536,6 +3512,139 @@
         <p14:creationId xmlns:p14="http://schemas.microsoft.com/office/powerpoint/2010/main" val="4052130581"/>
       </p:ext>
     </p:extLst>
+  </p:cSld>
+  <p:clrMapOvr>
+    <a:masterClrMapping/>
+  </p:clrMapOvr>
+</p:sld>
+</file>
+
+<file path=ppt/slides/slide2.xml><?xml version="1.0" encoding="utf-8"?>
+<p:sld xmlns:a="http://schemas.openxmlformats.org/drawingml/2006/main" xmlns:p="http://schemas.openxmlformats.org/presentationml/2006/main" xmlns:r="http://schemas.openxmlformats.org/officeDocument/2006/relationships">
+  <p:cSld>
+    <p:spTree>
+      <p:nvGrpSpPr>
+        <p:cNvPr id="1" name=""/>
+        <p:cNvGrpSpPr/>
+        <p:nvPr/>
+      </p:nvGrpSpPr>
+      <p:grpSpPr/>
+      <p:sp>
+        <p:nvSpPr>
+          <p:cNvPr id="3" name="TextBox 2"/>
+          <p:cNvSpPr txBox="1"/>
+          <p:nvPr/>
+        </p:nvSpPr>
+        <p:spPr>
+          <a:xfrm>
+            <a:off x="457200" y="274320"/>
+            <a:ext cx="8229600" cy="731520"/>
+          </a:xfrm>
+          <a:prstGeom prst="rect">
+            <a:avLst/>
+          </a:prstGeom>
+          <a:noFill/>
+        </p:spPr>
+        <p:txBody>
+          <a:bodyPr wrap="none">
+            <a:spAutoFit/>
+          </a:bodyPr>
+          <a:lstStyle/>
+          <a:p>
+            <a:r>
+              <a:rPr sz="2400" b="1"/>
+              <a:t>Regional Performance Anomaly Detection — Key Findings #2</a:t>
+            </a:r>
+          </a:p>
+        </p:txBody>
+      </p:sp>
+      <p:pic>
+        <p:nvPicPr>
+          <p:cNvPr id="4" name="Picture 3" descr="profit_by_region_category.png"/>
+          <p:cNvPicPr>
+            <a:picLocks noChangeAspect="1"/>
+          </p:cNvPicPr>
+          <p:nvPr/>
+        </p:nvPicPr>
+        <p:blipFill>
+          <a:blip r:embed="rId2"/>
+          <a:stretch>
+            <a:fillRect/>
+          </a:stretch>
+        </p:blipFill>
+        <p:spPr>
+          <a:xfrm>
+            <a:off x="457200" y="1188720"/>
+            <a:ext cx="8229600" cy="3840480"/>
+          </a:xfrm>
+          <a:prstGeom prst="rect">
+            <a:avLst/>
+          </a:prstGeom>
+        </p:spPr>
+      </p:pic>
+      <p:sp>
+        <p:nvSpPr>
+          <p:cNvPr id="5" name="TextBox 4"/>
+          <p:cNvSpPr txBox="1"/>
+          <p:nvPr/>
+        </p:nvSpPr>
+        <p:spPr>
+          <a:xfrm>
+            <a:off x="457200" y="5120640"/>
+            <a:ext cx="8229600" cy="1005840"/>
+          </a:xfrm>
+          <a:prstGeom prst="rect">
+            <a:avLst/>
+          </a:prstGeom>
+          <a:noFill/>
+        </p:spPr>
+        <p:txBody>
+          <a:bodyPr wrap="square">
+            <a:spAutoFit/>
+          </a:bodyPr>
+          <a:lstStyle/>
+          <a:p>
+            <a:r>
+              <a:rPr sz="1200"/>
+              <a:t>(Region × Category profit): no statistical outliers detected — similarly expected, since aggregation smooths extremes.</a:t>
+            </a:r>
+          </a:p>
+        </p:txBody>
+      </p:sp>
+      <p:sp>
+        <p:nvSpPr>
+          <p:cNvPr id="6" name="TextBox 5"/>
+          <p:cNvSpPr txBox="1"/>
+          <p:nvPr/>
+        </p:nvSpPr>
+        <p:spPr>
+          <a:xfrm>
+            <a:off x="457200" y="6309360"/>
+            <a:ext cx="8229600" cy="365760"/>
+          </a:xfrm>
+          <a:prstGeom prst="rect">
+            <a:avLst/>
+          </a:prstGeom>
+          <a:noFill/>
+        </p:spPr>
+        <p:txBody>
+          <a:bodyPr wrap="none">
+            <a:spAutoFit/>
+          </a:bodyPr>
+          <a:lstStyle/>
+          <a:p>
+            <a:r>
+              <a:rPr sz="900">
+                <a:solidFill>
+                  <a:srgbClr val="888888"/>
+                </a:solidFill>
+              </a:rPr>
+              <a:t>Source: Superstore Sales Dataset | Method: IQR-based outlier detection</a:t>
+            </a:r>
+          </a:p>
+        </p:txBody>
+      </p:sp>
+    </p:spTree>
   </p:cSld>
   <p:clrMapOvr>
     <a:masterClrMapping/>

</xml_diff>